<commit_message>
docs: refresh pitch media with the branded app tour
</commit_message>
<xml_diff>
--- a/presentation/GEvents-Pitch.pptx
+++ b/presentation/GEvents-Pitch.pptx
@@ -2,25 +2,25 @@
 <file path=ppt/presentation.xml><?xml version="1.0" encoding="utf-8"?>
 <p:presentation xmlns:p="http://schemas.openxmlformats.org/presentationml/2006/main">
   <p:sldMasterIdLst>
-    <p:sldMasterId xmlns:r="http://schemas.openxmlformats.org/officeDocument/2006/relationships" id="2147483648" r:id="R60d63e4c367d4063"/>
+    <p:sldMasterId xmlns:r="http://schemas.openxmlformats.org/officeDocument/2006/relationships" id="2147483648" r:id="Rdf58117e3c9c443c"/>
   </p:sldMasterIdLst>
   <p:notesMasterIdLst>
-    <p:notesMasterId xmlns:r="http://schemas.openxmlformats.org/officeDocument/2006/relationships" r:id="Rcc0591cfdabe44e7"/>
+    <p:notesMasterId xmlns:r="http://schemas.openxmlformats.org/officeDocument/2006/relationships" r:id="Rf4b51d2bdc4c436f"/>
   </p:notesMasterIdLst>
   <p:sldIdLst>
-    <p:sldId xmlns:r="http://schemas.openxmlformats.org/officeDocument/2006/relationships" id="256" r:id="R82dd649cab144a57"/>
-    <p:sldId xmlns:r="http://schemas.openxmlformats.org/officeDocument/2006/relationships" id="257" r:id="R10092d65f64d4f2e"/>
-    <p:sldId xmlns:r="http://schemas.openxmlformats.org/officeDocument/2006/relationships" id="258" r:id="R59d273a3bd4145f2"/>
-    <p:sldId xmlns:r="http://schemas.openxmlformats.org/officeDocument/2006/relationships" id="259" r:id="R77304637db8b4050"/>
-    <p:sldId xmlns:r="http://schemas.openxmlformats.org/officeDocument/2006/relationships" id="260" r:id="Rec9125b549c54208"/>
-    <p:sldId xmlns:r="http://schemas.openxmlformats.org/officeDocument/2006/relationships" id="261" r:id="Re5e76f9786e84dc5"/>
-    <p:sldId xmlns:r="http://schemas.openxmlformats.org/officeDocument/2006/relationships" id="262" r:id="R57c39ffbefa24e82"/>
-    <p:sldId xmlns:r="http://schemas.openxmlformats.org/officeDocument/2006/relationships" id="263" r:id="R84fc95c6dcc5498c"/>
-    <p:sldId xmlns:r="http://schemas.openxmlformats.org/officeDocument/2006/relationships" id="264" r:id="R51c66f5a6833455d"/>
-    <p:sldId xmlns:r="http://schemas.openxmlformats.org/officeDocument/2006/relationships" id="265" r:id="R7e1ee59301ca4b98"/>
-    <p:sldId xmlns:r="http://schemas.openxmlformats.org/officeDocument/2006/relationships" id="266" r:id="R92af6425e8404dd0"/>
-    <p:sldId xmlns:r="http://schemas.openxmlformats.org/officeDocument/2006/relationships" id="267" r:id="R0e6d654f93034703"/>
-    <p:sldId xmlns:r="http://schemas.openxmlformats.org/officeDocument/2006/relationships" id="268" r:id="R40d30bcc1cac402d"/>
+    <p:sldId xmlns:r="http://schemas.openxmlformats.org/officeDocument/2006/relationships" id="256" r:id="Rc338cdaf47944eae"/>
+    <p:sldId xmlns:r="http://schemas.openxmlformats.org/officeDocument/2006/relationships" id="257" r:id="R5db702c7c368471a"/>
+    <p:sldId xmlns:r="http://schemas.openxmlformats.org/officeDocument/2006/relationships" id="258" r:id="Rf3e94339ab6143e6"/>
+    <p:sldId xmlns:r="http://schemas.openxmlformats.org/officeDocument/2006/relationships" id="259" r:id="Red6fb187655e4658"/>
+    <p:sldId xmlns:r="http://schemas.openxmlformats.org/officeDocument/2006/relationships" id="260" r:id="R1df8cf6ae4924d65"/>
+    <p:sldId xmlns:r="http://schemas.openxmlformats.org/officeDocument/2006/relationships" id="261" r:id="R9fe52e25c428407a"/>
+    <p:sldId xmlns:r="http://schemas.openxmlformats.org/officeDocument/2006/relationships" id="262" r:id="Rcd90a15f3bf54cb3"/>
+    <p:sldId xmlns:r="http://schemas.openxmlformats.org/officeDocument/2006/relationships" id="263" r:id="R83884358dbac479c"/>
+    <p:sldId xmlns:r="http://schemas.openxmlformats.org/officeDocument/2006/relationships" id="264" r:id="R1ab38810759e4a6c"/>
+    <p:sldId xmlns:r="http://schemas.openxmlformats.org/officeDocument/2006/relationships" id="265" r:id="R7bc0e32a4b994204"/>
+    <p:sldId xmlns:r="http://schemas.openxmlformats.org/officeDocument/2006/relationships" id="266" r:id="R6d9e7c5de8ed4c0a"/>
+    <p:sldId xmlns:r="http://schemas.openxmlformats.org/officeDocument/2006/relationships" id="267" r:id="Rd8a7c72ccb23404f"/>
+    <p:sldId xmlns:r="http://schemas.openxmlformats.org/officeDocument/2006/relationships" id="268" r:id="R330882b71c7d46be"/>
   </p:sldIdLst>
   <p:sldSz cx="12192000" cy="6858000"/>
   <p:notesSz cx="6858000" cy="9144000"/>
@@ -1792,7 +1792,7 @@
   </p:cSld>
   <p:clrMap bg1="lt1" tx1="dk1" bg2="lt2" tx2="dk2" accent1="accent1" accent2="accent2" accent3="accent3" accent4="accent4" accent5="accent5" accent6="accent6" hlink="hlink" folHlink="folHlink"/>
   <p:sldLayoutIdLst>
-    <p:sldLayoutId xmlns:r="http://schemas.openxmlformats.org/officeDocument/2006/relationships" id="2147483649" r:id="Ra30564653296447a"/>
+    <p:sldLayoutId xmlns:r="http://schemas.openxmlformats.org/officeDocument/2006/relationships" id="2147483649" r:id="R7f054defdeee49c7"/>
   </p:sldLayoutIdLst>
   <p:txStyles>
     <p:titleStyle>
@@ -2347,7 +2347,7 @@
           <p:nvPr/>
         </p:nvPicPr>
         <p:blipFill>
-          <a:blip xmlns:r="http://schemas.openxmlformats.org/officeDocument/2006/relationships" xmlns:a="http://schemas.openxmlformats.org/drawingml/2006/main" r:embed="R5896276a0e704c05"/>
+          <a:blip xmlns:r="http://schemas.openxmlformats.org/officeDocument/2006/relationships" xmlns:a="http://schemas.openxmlformats.org/drawingml/2006/main" r:embed="Rd04615f0ec9c4280"/>
           <a:stretch xmlns:a="http://schemas.openxmlformats.org/drawingml/2006/main"/>
         </p:blipFill>
         <p:spPr>
@@ -2365,7 +2365,7 @@
           <p:cNvPr id="2" name="GEvents">
             <a:extLst xmlns:a="http://schemas.openxmlformats.org/drawingml/2006/main">
               <a:ext uri="{FF2B5EF4-FFF2-40B4-BE49-F238E27FC236}">
-                <a16:creationId xmlns:a16="http://schemas.microsoft.com/office/drawing/2014/main" id="{FB73D1BE-F3D2-459A-8558-61D43929EBF5}"/>
+                <a16:creationId xmlns:a16="http://schemas.microsoft.com/office/drawing/2014/main" id="{1B35CAF1-FB80-4F08-8C40-611CF467E40C}"/>
               </a:ext>
             </a:extLst>
           </p:cNvPr>
@@ -2422,7 +2422,7 @@
           <p:cNvPr id="3" name="The right people for events.&#10;The right events">
             <a:extLst xmlns:a="http://schemas.openxmlformats.org/drawingml/2006/main">
               <a:ext uri="{FF2B5EF4-FFF2-40B4-BE49-F238E27FC236}">
-                <a16:creationId xmlns:a16="http://schemas.microsoft.com/office/drawing/2014/main" id="{338ED038-C984-46A5-A5B6-5660C6EC1398}"/>
+                <a16:creationId xmlns:a16="http://schemas.microsoft.com/office/drawing/2014/main" id="{C6BCFCA3-D740-4BE0-8D9F-3BA841434B1F}"/>
               </a:ext>
             </a:extLst>
           </p:cNvPr>
@@ -2502,7 +2502,7 @@
           <p:cNvPr id="4" name="GDG Belgrade hackathon">
             <a:extLst xmlns:a="http://schemas.openxmlformats.org/drawingml/2006/main">
               <a:ext uri="{FF2B5EF4-FFF2-40B4-BE49-F238E27FC236}">
-                <a16:creationId xmlns:a16="http://schemas.microsoft.com/office/drawing/2014/main" id="{3EE38A98-E3FA-4941-8630-3D40BD62BC16}"/>
+                <a16:creationId xmlns:a16="http://schemas.microsoft.com/office/drawing/2014/main" id="{98D42EBD-005E-4AF9-BAC0-104F5CE4AAA3}"/>
               </a:ext>
             </a:extLst>
           </p:cNvPr>
@@ -2557,7 +2557,7 @@
     </p:spTree>
     <p:extLst>
       <p:ext uri="{BB962C8B-B14F-4D97-AF65-F5344CB8AC3E}">
-        <p14:creationId xmlns:p14="http://schemas.microsoft.com/office/powerpoint/2010/main" val="539981808"/>
+        <p14:creationId xmlns:p14="http://schemas.microsoft.com/office/powerpoint/2010/main" val="1449065310"/>
       </p:ext>
     </p:extLst>
   </p:cSld>
@@ -2588,7 +2588,7 @@
           <p:cNvPr id="4" name="The right fit creates the next opportunity">
             <a:extLst xmlns:a="http://schemas.openxmlformats.org/drawingml/2006/main">
               <a:ext uri="{FF2B5EF4-FFF2-40B4-BE49-F238E27FC236}">
-                <a16:creationId xmlns:a16="http://schemas.microsoft.com/office/drawing/2014/main" id="{CB9E6F5B-F83F-4124-BA3D-A31432894430}"/>
+                <a16:creationId xmlns:a16="http://schemas.microsoft.com/office/drawing/2014/main" id="{0D32BBA8-9E9E-45DA-AEFA-21893D5809BD}"/>
               </a:ext>
             </a:extLst>
           </p:cNvPr>
@@ -2645,7 +2645,7 @@
           <p:cNvPr id="2" name="GEvents&#10;Matching people and events in both di">
             <a:extLst xmlns:a="http://schemas.openxmlformats.org/drawingml/2006/main">
               <a:ext uri="{FF2B5EF4-FFF2-40B4-BE49-F238E27FC236}">
-                <a16:creationId xmlns:a16="http://schemas.microsoft.com/office/drawing/2014/main" id="{3DD46808-D85E-4224-AD7C-962E1CA4C543}"/>
+                <a16:creationId xmlns:a16="http://schemas.microsoft.com/office/drawing/2014/main" id="{1BC7C276-59D4-47CC-AD65-7583253AE504}"/>
               </a:ext>
             </a:extLst>
           </p:cNvPr>
@@ -2725,7 +2725,7 @@
           <p:cNvPr id="3" name="Our next step is to prove the value with orga">
             <a:extLst xmlns:a="http://schemas.openxmlformats.org/drawingml/2006/main">
               <a:ext uri="{FF2B5EF4-FFF2-40B4-BE49-F238E27FC236}">
-                <a16:creationId xmlns:a16="http://schemas.microsoft.com/office/drawing/2014/main" id="{43BC2D82-7A60-47C2-AEE6-41E9A380DD87}"/>
+                <a16:creationId xmlns:a16="http://schemas.microsoft.com/office/drawing/2014/main" id="{A222F6F0-D34E-42CD-917B-89D2DC1BAAED}"/>
               </a:ext>
             </a:extLst>
           </p:cNvPr>
@@ -2780,7 +2780,7 @@
     </p:spTree>
     <p:extLst>
       <p:ext uri="{BB962C8B-B14F-4D97-AF65-F5344CB8AC3E}">
-        <p14:creationId xmlns:p14="http://schemas.microsoft.com/office/powerpoint/2010/main" val="1177223668"/>
+        <p14:creationId xmlns:p14="http://schemas.microsoft.com/office/powerpoint/2010/main" val="1677460643"/>
       </p:ext>
     </p:extLst>
   </p:cSld>
@@ -2811,7 +2811,7 @@
           <p:cNvPr id="3" name="Profile inputs">
             <a:extLst xmlns:a="http://schemas.openxmlformats.org/drawingml/2006/main">
               <a:ext uri="{FF2B5EF4-FFF2-40B4-BE49-F238E27FC236}">
-                <a16:creationId xmlns:a16="http://schemas.microsoft.com/office/drawing/2014/main" id="{68431657-1350-4C69-A292-47492429354C}"/>
+                <a16:creationId xmlns:a16="http://schemas.microsoft.com/office/drawing/2014/main" id="{B73A16C5-2DD4-47E1-B4F1-82A5495FE776}"/>
               </a:ext>
             </a:extLst>
           </p:cNvPr>
@@ -2872,7 +2872,7 @@
           <p:nvPr/>
         </p:nvPicPr>
         <p:blipFill>
-          <a:blip xmlns:r="http://schemas.openxmlformats.org/officeDocument/2006/relationships" xmlns:a="http://schemas.openxmlformats.org/drawingml/2006/main" r:embed="Rb9789b673ecf44a5"/>
+          <a:blip xmlns:r="http://schemas.openxmlformats.org/officeDocument/2006/relationships" xmlns:a="http://schemas.openxmlformats.org/drawingml/2006/main" r:embed="R9dbde9508dbd4eee"/>
           <a:stretch xmlns:a="http://schemas.openxmlformats.org/drawingml/2006/main"/>
         </p:blipFill>
         <p:spPr>
@@ -2888,7 +2888,7 @@
     </p:spTree>
     <p:extLst>
       <p:ext uri="{BB962C8B-B14F-4D97-AF65-F5344CB8AC3E}">
-        <p14:creationId xmlns:p14="http://schemas.microsoft.com/office/powerpoint/2010/main" val="975303105"/>
+        <p14:creationId xmlns:p14="http://schemas.microsoft.com/office/powerpoint/2010/main" val="854508796"/>
       </p:ext>
     </p:extLst>
   </p:cSld>
@@ -2919,7 +2919,7 @@
           <p:cNvPr id="3" name="Recommendation evidence">
             <a:extLst xmlns:a="http://schemas.openxmlformats.org/drawingml/2006/main">
               <a:ext uri="{FF2B5EF4-FFF2-40B4-BE49-F238E27FC236}">
-                <a16:creationId xmlns:a16="http://schemas.microsoft.com/office/drawing/2014/main" id="{40D3D49C-AFCC-48D0-95DD-4D5C8C2B43A5}"/>
+                <a16:creationId xmlns:a16="http://schemas.microsoft.com/office/drawing/2014/main" id="{54141334-BF99-460D-9557-CEAE27178BD0}"/>
               </a:ext>
             </a:extLst>
           </p:cNvPr>
@@ -2980,7 +2980,7 @@
           <p:nvPr/>
         </p:nvPicPr>
         <p:blipFill>
-          <a:blip xmlns:r="http://schemas.openxmlformats.org/officeDocument/2006/relationships" xmlns:a="http://schemas.openxmlformats.org/drawingml/2006/main" r:embed="Rc723e59278014bd7"/>
+          <a:blip xmlns:r="http://schemas.openxmlformats.org/officeDocument/2006/relationships" xmlns:a="http://schemas.openxmlformats.org/drawingml/2006/main" r:embed="R407347f422e04250"/>
           <a:stretch xmlns:a="http://schemas.openxmlformats.org/drawingml/2006/main"/>
         </p:blipFill>
         <p:spPr>
@@ -2996,7 +2996,7 @@
     </p:spTree>
     <p:extLst>
       <p:ext uri="{BB962C8B-B14F-4D97-AF65-F5344CB8AC3E}">
-        <p14:creationId xmlns:p14="http://schemas.microsoft.com/office/powerpoint/2010/main" val="1382383964"/>
+        <p14:creationId xmlns:p14="http://schemas.microsoft.com/office/powerpoint/2010/main" val="1763516783"/>
       </p:ext>
     </p:extLst>
   </p:cSld>
@@ -3027,7 +3027,7 @@
           <p:cNvPr id="3" name="Organizer decisions">
             <a:extLst xmlns:a="http://schemas.openxmlformats.org/drawingml/2006/main">
               <a:ext uri="{FF2B5EF4-FFF2-40B4-BE49-F238E27FC236}">
-                <a16:creationId xmlns:a16="http://schemas.microsoft.com/office/drawing/2014/main" id="{C10CEFC7-C9AB-4846-B67A-547B36A5DAF2}"/>
+                <a16:creationId xmlns:a16="http://schemas.microsoft.com/office/drawing/2014/main" id="{70FEF958-824B-4F11-9BDE-42D4C6768E7C}"/>
               </a:ext>
             </a:extLst>
           </p:cNvPr>
@@ -3088,7 +3088,7 @@
           <p:nvPr/>
         </p:nvPicPr>
         <p:blipFill>
-          <a:blip xmlns:r="http://schemas.openxmlformats.org/officeDocument/2006/relationships" xmlns:a="http://schemas.openxmlformats.org/drawingml/2006/main" r:embed="Rd5f5b12aac0a4821"/>
+          <a:blip xmlns:r="http://schemas.openxmlformats.org/officeDocument/2006/relationships" xmlns:a="http://schemas.openxmlformats.org/drawingml/2006/main" r:embed="R2b99b2396ecd459c"/>
           <a:stretch xmlns:a="http://schemas.openxmlformats.org/drawingml/2006/main"/>
         </p:blipFill>
         <p:spPr>
@@ -3104,7 +3104,7 @@
     </p:spTree>
     <p:extLst>
       <p:ext uri="{BB962C8B-B14F-4D97-AF65-F5344CB8AC3E}">
-        <p14:creationId xmlns:p14="http://schemas.microsoft.com/office/powerpoint/2010/main" val="2003762237"/>
+        <p14:creationId xmlns:p14="http://schemas.microsoft.com/office/powerpoint/2010/main" val="187606433"/>
       </p:ext>
     </p:extLst>
   </p:cSld>
@@ -3135,7 +3135,7 @@
           <p:cNvPr id="7" name="Finding the right fit takes work">
             <a:extLst xmlns:a="http://schemas.openxmlformats.org/drawingml/2006/main">
               <a:ext uri="{FF2B5EF4-FFF2-40B4-BE49-F238E27FC236}">
-                <a16:creationId xmlns:a16="http://schemas.microsoft.com/office/drawing/2014/main" id="{F2938206-5A46-460C-80B8-8FFDD01AC93F}"/>
+                <a16:creationId xmlns:a16="http://schemas.microsoft.com/office/drawing/2014/main" id="{49C2CD7A-811A-4B9B-9632-CBD7534178E1}"/>
               </a:ext>
             </a:extLst>
           </p:cNvPr>
@@ -3192,7 +3192,7 @@
           <p:cNvPr id="2" name="Organizations">
             <a:extLst xmlns:a="http://schemas.openxmlformats.org/drawingml/2006/main">
               <a:ext uri="{FF2B5EF4-FFF2-40B4-BE49-F238E27FC236}">
-                <a16:creationId xmlns:a16="http://schemas.microsoft.com/office/drawing/2014/main" id="{B56D96D0-81F8-496A-A28F-DDD180A5AF3A}"/>
+                <a16:creationId xmlns:a16="http://schemas.microsoft.com/office/drawing/2014/main" id="{2E8DB4DD-8523-4FC2-9D7D-383190EAA175}"/>
               </a:ext>
             </a:extLst>
           </p:cNvPr>
@@ -3249,7 +3249,7 @@
           <p:cNvPr id="3" name="Suitable people&#10;Across event roles&#10;Less recru">
             <a:extLst xmlns:a="http://schemas.openxmlformats.org/drawingml/2006/main">
               <a:ext uri="{FF2B5EF4-FFF2-40B4-BE49-F238E27FC236}">
-                <a16:creationId xmlns:a16="http://schemas.microsoft.com/office/drawing/2014/main" id="{AE73DD2A-4E41-40A7-8F92-3A7007847B7C}"/>
+                <a16:creationId xmlns:a16="http://schemas.microsoft.com/office/drawing/2014/main" id="{E421EA4E-EB2D-4BB3-8869-A0D2BC501085}"/>
               </a:ext>
             </a:extLst>
           </p:cNvPr>
@@ -3352,7 +3352,7 @@
           <p:cNvPr id="4" name="People">
             <a:extLst xmlns:a="http://schemas.openxmlformats.org/drawingml/2006/main">
               <a:ext uri="{FF2B5EF4-FFF2-40B4-BE49-F238E27FC236}">
-                <a16:creationId xmlns:a16="http://schemas.microsoft.com/office/drawing/2014/main" id="{04AED6B0-7DF5-4959-89E1-4B9847FD0FF3}"/>
+                <a16:creationId xmlns:a16="http://schemas.microsoft.com/office/drawing/2014/main" id="{169D4A45-B26C-4396-8683-0E9CD1D43D98}"/>
               </a:ext>
             </a:extLst>
           </p:cNvPr>
@@ -3409,7 +3409,7 @@
           <p:cNvPr id="5" name="Relevant opportunities&#10;A role they want&#10;A rea">
             <a:extLst xmlns:a="http://schemas.openxmlformats.org/drawingml/2006/main">
               <a:ext uri="{FF2B5EF4-FFF2-40B4-BE49-F238E27FC236}">
-                <a16:creationId xmlns:a16="http://schemas.microsoft.com/office/drawing/2014/main" id="{2FDC23B3-ACAB-4A50-B89C-AD900D9148AB}"/>
+                <a16:creationId xmlns:a16="http://schemas.microsoft.com/office/drawing/2014/main" id="{4BF7CE95-2A86-4B68-9546-E109DC3A9666}"/>
               </a:ext>
             </a:extLst>
           </p:cNvPr>
@@ -3512,7 +3512,7 @@
           <p:cNvPr id="6" name="First customer: organizations running recurri">
             <a:extLst xmlns:a="http://schemas.openxmlformats.org/drawingml/2006/main">
               <a:ext uri="{FF2B5EF4-FFF2-40B4-BE49-F238E27FC236}">
-                <a16:creationId xmlns:a16="http://schemas.microsoft.com/office/drawing/2014/main" id="{104DD6FC-542E-4FBF-8BBB-65631764D06E}"/>
+                <a16:creationId xmlns:a16="http://schemas.microsoft.com/office/drawing/2014/main" id="{DB43A12B-E804-44A6-A779-7EA17DAF3944}"/>
               </a:ext>
             </a:extLst>
           </p:cNvPr>
@@ -3567,7 +3567,7 @@
     </p:spTree>
     <p:extLst>
       <p:ext uri="{BB962C8B-B14F-4D97-AF65-F5344CB8AC3E}">
-        <p14:creationId xmlns:p14="http://schemas.microsoft.com/office/powerpoint/2010/main" val="1631565300"/>
+        <p14:creationId xmlns:p14="http://schemas.microsoft.com/office/powerpoint/2010/main" val="944272206"/>
       </p:ext>
     </p:extLst>
   </p:cSld>
@@ -3598,7 +3598,7 @@
           <p:cNvPr id="12" name="The matchmaking algorithm">
             <a:extLst xmlns:a="http://schemas.openxmlformats.org/drawingml/2006/main">
               <a:ext uri="{FF2B5EF4-FFF2-40B4-BE49-F238E27FC236}">
-                <a16:creationId xmlns:a16="http://schemas.microsoft.com/office/drawing/2014/main" id="{0F4E4EC9-A090-4BBF-A6FC-B02D1EE98DFE}"/>
+                <a16:creationId xmlns:a16="http://schemas.microsoft.com/office/drawing/2014/main" id="{D937F4D6-0BCE-435E-9E32-0DA2E3D2C35C}"/>
               </a:ext>
             </a:extLst>
           </p:cNvPr>
@@ -3655,7 +3655,7 @@
           <p:cNvPr id="2" name="1">
             <a:extLst xmlns:a="http://schemas.openxmlformats.org/drawingml/2006/main">
               <a:ext uri="{FF2B5EF4-FFF2-40B4-BE49-F238E27FC236}">
-                <a16:creationId xmlns:a16="http://schemas.microsoft.com/office/drawing/2014/main" id="{2EEA15F7-48B7-4938-AA25-6D1F16BC4C7D}"/>
+                <a16:creationId xmlns:a16="http://schemas.microsoft.com/office/drawing/2014/main" id="{72876EA8-609D-4BA0-A356-C1C8242ED557}"/>
               </a:ext>
             </a:extLst>
           </p:cNvPr>
@@ -3712,7 +3712,7 @@
           <p:cNvPr id="3" name="Eligibility">
             <a:extLst xmlns:a="http://schemas.openxmlformats.org/drawingml/2006/main">
               <a:ext uri="{FF2B5EF4-FFF2-40B4-BE49-F238E27FC236}">
-                <a16:creationId xmlns:a16="http://schemas.microsoft.com/office/drawing/2014/main" id="{C994DFBA-AD66-428C-BEA7-BBE5A489BE39}"/>
+                <a16:creationId xmlns:a16="http://schemas.microsoft.com/office/drawing/2014/main" id="{4E477FDA-377E-4FED-95CD-CCD0F17069ED}"/>
               </a:ext>
             </a:extLst>
           </p:cNvPr>
@@ -3769,7 +3769,7 @@
           <p:cNvPr id="4" name="Requirements&#10;Dates and capacity">
             <a:extLst xmlns:a="http://schemas.openxmlformats.org/drawingml/2006/main">
               <a:ext uri="{FF2B5EF4-FFF2-40B4-BE49-F238E27FC236}">
-                <a16:creationId xmlns:a16="http://schemas.microsoft.com/office/drawing/2014/main" id="{60F6F731-3D15-4137-A3F5-B4B861CC9759}"/>
+                <a16:creationId xmlns:a16="http://schemas.microsoft.com/office/drawing/2014/main" id="{9BBDCBED-8569-4408-9CF9-65276C049E45}"/>
               </a:ext>
             </a:extLst>
           </p:cNvPr>
@@ -3849,7 +3849,7 @@
           <p:cNvPr id="5" name="2">
             <a:extLst xmlns:a="http://schemas.openxmlformats.org/drawingml/2006/main">
               <a:ext uri="{FF2B5EF4-FFF2-40B4-BE49-F238E27FC236}">
-                <a16:creationId xmlns:a16="http://schemas.microsoft.com/office/drawing/2014/main" id="{EB270DEB-5D09-46EA-93DC-2110FE4FA9B3}"/>
+                <a16:creationId xmlns:a16="http://schemas.microsoft.com/office/drawing/2014/main" id="{44AAE29C-B156-44CB-9AC7-9C700E050B31}"/>
               </a:ext>
             </a:extLst>
           </p:cNvPr>
@@ -3906,7 +3906,7 @@
           <p:cNvPr id="6" name="Relevance">
             <a:extLst xmlns:a="http://schemas.openxmlformats.org/drawingml/2006/main">
               <a:ext uri="{FF2B5EF4-FFF2-40B4-BE49-F238E27FC236}">
-                <a16:creationId xmlns:a16="http://schemas.microsoft.com/office/drawing/2014/main" id="{F8814AD1-729D-44F1-966A-711CE0E5F04F}"/>
+                <a16:creationId xmlns:a16="http://schemas.microsoft.com/office/drawing/2014/main" id="{6A28D722-D5E1-4340-B80C-84516D0873FE}"/>
               </a:ext>
             </a:extLst>
           </p:cNvPr>
@@ -3963,7 +3963,7 @@
           <p:cNvPr id="7" name="Skills and interests&#10;Learning goals and roles">
             <a:extLst xmlns:a="http://schemas.openxmlformats.org/drawingml/2006/main">
               <a:ext uri="{FF2B5EF4-FFF2-40B4-BE49-F238E27FC236}">
-                <a16:creationId xmlns:a16="http://schemas.microsoft.com/office/drawing/2014/main" id="{5C3873ED-B01D-429C-BF35-A9E1837DAB37}"/>
+                <a16:creationId xmlns:a16="http://schemas.microsoft.com/office/drawing/2014/main" id="{B2EDA8EF-7C1B-45B4-93CE-79A82AE7AC7D}"/>
               </a:ext>
             </a:extLst>
           </p:cNvPr>
@@ -4043,7 +4043,7 @@
           <p:cNvPr id="8" name="3">
             <a:extLst xmlns:a="http://schemas.openxmlformats.org/drawingml/2006/main">
               <a:ext uri="{FF2B5EF4-FFF2-40B4-BE49-F238E27FC236}">
-                <a16:creationId xmlns:a16="http://schemas.microsoft.com/office/drawing/2014/main" id="{EFA490FD-FE1E-43A3-B841-1D5B78EC7A2E}"/>
+                <a16:creationId xmlns:a16="http://schemas.microsoft.com/office/drawing/2014/main" id="{7C84C7A0-E973-4497-93FB-5E06719C4EE0}"/>
               </a:ext>
             </a:extLst>
           </p:cNvPr>
@@ -4100,7 +4100,7 @@
           <p:cNvPr id="9" name="Human choice">
             <a:extLst xmlns:a="http://schemas.openxmlformats.org/drawingml/2006/main">
               <a:ext uri="{FF2B5EF4-FFF2-40B4-BE49-F238E27FC236}">
-                <a16:creationId xmlns:a16="http://schemas.microsoft.com/office/drawing/2014/main" id="{E77FC448-15C5-48D9-B60F-614BF50B38E1}"/>
+                <a16:creationId xmlns:a16="http://schemas.microsoft.com/office/drawing/2014/main" id="{63FDDE7A-7282-4652-89B7-0EFDBE98D028}"/>
               </a:ext>
             </a:extLst>
           </p:cNvPr>
@@ -4157,7 +4157,7 @@
           <p:cNvPr id="10" name="Explain the suggestion&#10;Let both sides decide">
             <a:extLst xmlns:a="http://schemas.openxmlformats.org/drawingml/2006/main">
               <a:ext uri="{FF2B5EF4-FFF2-40B4-BE49-F238E27FC236}">
-                <a16:creationId xmlns:a16="http://schemas.microsoft.com/office/drawing/2014/main" id="{2C5DC17F-E6B4-44A3-89EC-63AC11D75356}"/>
+                <a16:creationId xmlns:a16="http://schemas.microsoft.com/office/drawing/2014/main" id="{ED566A5A-9271-4D52-8CF4-A3ACF61E830A}"/>
               </a:ext>
             </a:extLst>
           </p:cNvPr>
@@ -4237,7 +4237,7 @@
           <p:cNvPr id="11" name="Google EmbeddingGemma compares meaning. Eligi">
             <a:extLst xmlns:a="http://schemas.openxmlformats.org/drawingml/2006/main">
               <a:ext uri="{FF2B5EF4-FFF2-40B4-BE49-F238E27FC236}">
-                <a16:creationId xmlns:a16="http://schemas.microsoft.com/office/drawing/2014/main" id="{4F8428CE-258C-4416-896F-3B4A69A5B61C}"/>
+                <a16:creationId xmlns:a16="http://schemas.microsoft.com/office/drawing/2014/main" id="{BB49AA82-5D31-4197-89F6-7307C03CDB2C}"/>
               </a:ext>
             </a:extLst>
           </p:cNvPr>
@@ -4292,7 +4292,7 @@
     </p:spTree>
     <p:extLst>
       <p:ext uri="{BB962C8B-B14F-4D97-AF65-F5344CB8AC3E}">
-        <p14:creationId xmlns:p14="http://schemas.microsoft.com/office/powerpoint/2010/main" val="215869083"/>
+        <p14:creationId xmlns:p14="http://schemas.microsoft.com/office/powerpoint/2010/main" val="567004063"/>
       </p:ext>
     </p:extLst>
   </p:cSld>
@@ -4336,7 +4336,7 @@
           </p:nvPr>
         </p:nvPicPr>
         <p:blipFill>
-          <a:blip r:embed="Racdb7b8c6cf54a20"/>
+          <a:blip r:embed="R2cbb25eb5387430f"/>
           <a:stretch/>
         </p:blipFill>
         <p:spPr>
@@ -4352,7 +4352,7 @@
     </p:spTree>
     <p:extLst>
       <p:ext uri="{BB962C8B-B14F-4D97-AF65-F5344CB8AC3E}">
-        <p14:creationId val="1396808828"/>
+        <p14:creationId val="1665700596"/>
       </p:ext>
     </p:extLst>
   </p:cSld>
@@ -4405,7 +4405,7 @@
           <p:cNvPr id="6" name="What we tested and learned">
             <a:extLst xmlns:a="http://schemas.openxmlformats.org/drawingml/2006/main">
               <a:ext uri="{FF2B5EF4-FFF2-40B4-BE49-F238E27FC236}">
-                <a16:creationId xmlns:a16="http://schemas.microsoft.com/office/drawing/2014/main" id="{31491A38-E3DD-4D5B-9289-CCB06AB31925}"/>
+                <a16:creationId xmlns:a16="http://schemas.microsoft.com/office/drawing/2014/main" id="{1A32C174-F97C-41E2-9ADF-0CFBF8C59B06}"/>
               </a:ext>
             </a:extLst>
           </p:cNvPr>
@@ -4462,7 +4462,7 @@
           <p:cNvPr id="2" name="50 / 50">
             <a:extLst xmlns:a="http://schemas.openxmlformats.org/drawingml/2006/main">
               <a:ext uri="{FF2B5EF4-FFF2-40B4-BE49-F238E27FC236}">
-                <a16:creationId xmlns:a16="http://schemas.microsoft.com/office/drawing/2014/main" id="{7892BD6E-E9E8-4682-BE4C-B4B1537E49B8}"/>
+                <a16:creationId xmlns:a16="http://schemas.microsoft.com/office/drawing/2014/main" id="{1F23AA65-6AA6-45D9-B190-DF72EC7ECF40}"/>
               </a:ext>
             </a:extLst>
           </p:cNvPr>
@@ -4519,7 +4519,7 @@
           <p:cNvPr id="3" name="Diagnostic checks passed">
             <a:extLst xmlns:a="http://schemas.openxmlformats.org/drawingml/2006/main">
               <a:ext uri="{FF2B5EF4-FFF2-40B4-BE49-F238E27FC236}">
-                <a16:creationId xmlns:a16="http://schemas.microsoft.com/office/drawing/2014/main" id="{6C322D38-D1BC-4C7B-80B0-C50C72181112}"/>
+                <a16:creationId xmlns:a16="http://schemas.microsoft.com/office/drawing/2014/main" id="{3004E5D0-4A5D-49F8-82C8-E4448B11BE6C}"/>
               </a:ext>
             </a:extLst>
           </p:cNvPr>
@@ -4576,7 +4576,7 @@
           <p:cNvPr id="4" name="7 fictional profiles&#10;2 synthetic events&#10;Real ">
             <a:extLst xmlns:a="http://schemas.openxmlformats.org/drawingml/2006/main">
               <a:ext uri="{FF2B5EF4-FFF2-40B4-BE49-F238E27FC236}">
-                <a16:creationId xmlns:a16="http://schemas.microsoft.com/office/drawing/2014/main" id="{CB9E8344-9E48-41D0-8FE0-06135CFDABCC}"/>
+                <a16:creationId xmlns:a16="http://schemas.microsoft.com/office/drawing/2014/main" id="{AB6CA087-47A7-42F5-8294-C831971ADE18}"/>
               </a:ext>
             </a:extLst>
           </p:cNvPr>
@@ -4679,7 +4679,7 @@
           <p:cNvPr id="5" name="Small diagnostic sample. Real user research i">
             <a:extLst xmlns:a="http://schemas.openxmlformats.org/drawingml/2006/main">
               <a:ext uri="{FF2B5EF4-FFF2-40B4-BE49-F238E27FC236}">
-                <a16:creationId xmlns:a16="http://schemas.microsoft.com/office/drawing/2014/main" id="{20FFA772-C788-4D6A-A6DC-A42C6F91232E}"/>
+                <a16:creationId xmlns:a16="http://schemas.microsoft.com/office/drawing/2014/main" id="{01C4C7DB-3947-44F4-9B6D-24A2817EDA24}"/>
               </a:ext>
             </a:extLst>
           </p:cNvPr>
@@ -4734,7 +4734,7 @@
     </p:spTree>
     <p:extLst>
       <p:ext uri="{BB962C8B-B14F-4D97-AF65-F5344CB8AC3E}">
-        <p14:creationId xmlns:p14="http://schemas.microsoft.com/office/powerpoint/2010/main" val="1972941907"/>
+        <p14:creationId xmlns:p14="http://schemas.microsoft.com/office/powerpoint/2010/main" val="804599002"/>
       </p:ext>
     </p:extLst>
   </p:cSld>
@@ -4765,7 +4765,7 @@
           <p:cNvPr id="9" name="Google technology and the pilot architecture">
             <a:extLst xmlns:a="http://schemas.openxmlformats.org/drawingml/2006/main">
               <a:ext uri="{FF2B5EF4-FFF2-40B4-BE49-F238E27FC236}">
-                <a16:creationId xmlns:a16="http://schemas.microsoft.com/office/drawing/2014/main" id="{D7CFAE76-6A2E-4128-9F39-8B84D65CE4C0}"/>
+                <a16:creationId xmlns:a16="http://schemas.microsoft.com/office/drawing/2014/main" id="{6CF1DFA8-3622-42C1-8A13-59C876DD4425}"/>
               </a:ext>
             </a:extLst>
           </p:cNvPr>
@@ -4822,7 +4822,7 @@
           <p:cNvPr id="2" name="Application">
             <a:extLst xmlns:a="http://schemas.openxmlformats.org/drawingml/2006/main">
               <a:ext uri="{FF2B5EF4-FFF2-40B4-BE49-F238E27FC236}">
-                <a16:creationId xmlns:a16="http://schemas.microsoft.com/office/drawing/2014/main" id="{168052B3-BA18-4B3C-9963-8CA0CF8CC7C2}"/>
+                <a16:creationId xmlns:a16="http://schemas.microsoft.com/office/drawing/2014/main" id="{D6A9F66F-4F51-4FFF-8721-D3D5ADD3360F}"/>
               </a:ext>
             </a:extLst>
           </p:cNvPr>
@@ -4879,7 +4879,7 @@
           <p:cNvPr id="3" name="React and authenticated Node API">
             <a:extLst xmlns:a="http://schemas.openxmlformats.org/drawingml/2006/main">
               <a:ext uri="{FF2B5EF4-FFF2-40B4-BE49-F238E27FC236}">
-                <a16:creationId xmlns:a16="http://schemas.microsoft.com/office/drawing/2014/main" id="{802621DE-86BC-43E6-A96D-BE6C7D3EF73E}"/>
+                <a16:creationId xmlns:a16="http://schemas.microsoft.com/office/drawing/2014/main" id="{01C8CD6F-AE05-4478-BF3E-805235D2FDB9}"/>
               </a:ext>
             </a:extLst>
           </p:cNvPr>
@@ -4936,7 +4936,7 @@
           <p:cNvPr id="4" name="Identity and data">
             <a:extLst xmlns:a="http://schemas.openxmlformats.org/drawingml/2006/main">
               <a:ext uri="{FF2B5EF4-FFF2-40B4-BE49-F238E27FC236}">
-                <a16:creationId xmlns:a16="http://schemas.microsoft.com/office/drawing/2014/main" id="{04315EAF-213F-4094-A808-09C59732E32B}"/>
+                <a16:creationId xmlns:a16="http://schemas.microsoft.com/office/drawing/2014/main" id="{B72D3390-ABAA-4F96-9151-628774D28403}"/>
               </a:ext>
             </a:extLst>
           </p:cNvPr>
@@ -4993,7 +4993,7 @@
           <p:cNvPr id="5" name="Firebase Authentication, Firestore and privat">
             <a:extLst xmlns:a="http://schemas.openxmlformats.org/drawingml/2006/main">
               <a:ext uri="{FF2B5EF4-FFF2-40B4-BE49-F238E27FC236}">
-                <a16:creationId xmlns:a16="http://schemas.microsoft.com/office/drawing/2014/main" id="{73A37D00-2DB8-4F1C-A52E-F03902BBAFF8}"/>
+                <a16:creationId xmlns:a16="http://schemas.microsoft.com/office/drawing/2014/main" id="{15CD52CF-567F-4B5C-9099-23F0ADC9CBF8}"/>
               </a:ext>
             </a:extLst>
           </p:cNvPr>
@@ -5050,7 +5050,7 @@
           <p:cNvPr id="6" name="Matching">
             <a:extLst xmlns:a="http://schemas.openxmlformats.org/drawingml/2006/main">
               <a:ext uri="{FF2B5EF4-FFF2-40B4-BE49-F238E27FC236}">
-                <a16:creationId xmlns:a16="http://schemas.microsoft.com/office/drawing/2014/main" id="{E8087F92-E6C4-4885-8192-FC6E12743CCC}"/>
+                <a16:creationId xmlns:a16="http://schemas.microsoft.com/office/drawing/2014/main" id="{8D9779B3-5949-4264-9E23-2476CD154F35}"/>
               </a:ext>
             </a:extLst>
           </p:cNvPr>
@@ -5107,7 +5107,7 @@
           <p:cNvPr id="7" name="Gemma extraction and EmbeddingGemma retrieval">
             <a:extLst xmlns:a="http://schemas.openxmlformats.org/drawingml/2006/main">
               <a:ext uri="{FF2B5EF4-FFF2-40B4-BE49-F238E27FC236}">
-                <a16:creationId xmlns:a16="http://schemas.microsoft.com/office/drawing/2014/main" id="{70C81241-6081-4CE0-80DC-7B04AB0B5D9F}"/>
+                <a16:creationId xmlns:a16="http://schemas.microsoft.com/office/drawing/2014/main" id="{8B097529-5B8C-44D4-92CE-4638C8F7510E}"/>
               </a:ext>
             </a:extLst>
           </p:cNvPr>
@@ -5164,7 +5164,7 @@
           <p:cNvPr id="8" name="Local model evidence. Cloud deployment and pr">
             <a:extLst xmlns:a="http://schemas.openxmlformats.org/drawingml/2006/main">
               <a:ext uri="{FF2B5EF4-FFF2-40B4-BE49-F238E27FC236}">
-                <a16:creationId xmlns:a16="http://schemas.microsoft.com/office/drawing/2014/main" id="{8732FAFA-1A89-4472-B25B-781E1BD89EE4}"/>
+                <a16:creationId xmlns:a16="http://schemas.microsoft.com/office/drawing/2014/main" id="{1093CC1A-579A-4A7E-A9D5-8E4C36161F11}"/>
               </a:ext>
             </a:extLst>
           </p:cNvPr>
@@ -5219,7 +5219,7 @@
     </p:spTree>
     <p:extLst>
       <p:ext uri="{BB962C8B-B14F-4D97-AF65-F5344CB8AC3E}">
-        <p14:creationId xmlns:p14="http://schemas.microsoft.com/office/powerpoint/2010/main" val="493192055"/>
+        <p14:creationId xmlns:p14="http://schemas.microsoft.com/office/powerpoint/2010/main" val="1985229428"/>
       </p:ext>
     </p:extLst>
   </p:cSld>
@@ -5250,7 +5250,7 @@
           <p:cNvPr id="4" name="Our position in an existing market">
             <a:extLst xmlns:a="http://schemas.openxmlformats.org/drawingml/2006/main">
               <a:ext uri="{FF2B5EF4-FFF2-40B4-BE49-F238E27FC236}">
-                <a16:creationId xmlns:a16="http://schemas.microsoft.com/office/drawing/2014/main" id="{246E944E-5A5C-488B-B622-744E2D24D2D2}"/>
+                <a16:creationId xmlns:a16="http://schemas.microsoft.com/office/drawing/2014/main" id="{7EF1A6BA-9F2B-461C-BAFC-C1D780B21AF1}"/>
               </a:ext>
             </a:extLst>
           </p:cNvPr>
@@ -5307,7 +5307,7 @@
           <p:cNvPr id="2" name="Brella and Swapcard already offer event match">
             <a:extLst xmlns:a="http://schemas.openxmlformats.org/drawingml/2006/main">
               <a:ext uri="{FF2B5EF4-FFF2-40B4-BE49-F238E27FC236}">
-                <a16:creationId xmlns:a16="http://schemas.microsoft.com/office/drawing/2014/main" id="{46249F93-B547-4F88-8C83-3FA66C642FFC}"/>
+                <a16:creationId xmlns:a16="http://schemas.microsoft.com/office/drawing/2014/main" id="{1B93F1AD-8951-44A6-A627-3940D7700489}"/>
               </a:ext>
             </a:extLst>
           </p:cNvPr>
@@ -5392,7 +5392,7 @@
           <p:cNvPr id="3" name="A proposed distinction to validate with custo">
             <a:extLst xmlns:a="http://schemas.openxmlformats.org/drawingml/2006/main">
               <a:ext uri="{FF2B5EF4-FFF2-40B4-BE49-F238E27FC236}">
-                <a16:creationId xmlns:a16="http://schemas.microsoft.com/office/drawing/2014/main" id="{862C9589-1CDC-4354-9CDF-898A31AFE46E}"/>
+                <a16:creationId xmlns:a16="http://schemas.microsoft.com/office/drawing/2014/main" id="{0EFE75F5-A581-4037-AD7D-5642F397E785}"/>
               </a:ext>
             </a:extLst>
           </p:cNvPr>
@@ -5447,7 +5447,7 @@
     </p:spTree>
     <p:extLst>
       <p:ext uri="{BB962C8B-B14F-4D97-AF65-F5344CB8AC3E}">
-        <p14:creationId xmlns:p14="http://schemas.microsoft.com/office/powerpoint/2010/main" val="69229785"/>
+        <p14:creationId xmlns:p14="http://schemas.microsoft.com/office/powerpoint/2010/main" val="2064026180"/>
       </p:ext>
     </p:extLst>
   </p:cSld>
@@ -5478,7 +5478,7 @@
           <p:cNvPr id="7" name="Organizations pay for better recruitment">
             <a:extLst xmlns:a="http://schemas.openxmlformats.org/drawingml/2006/main">
               <a:ext uri="{FF2B5EF4-FFF2-40B4-BE49-F238E27FC236}">
-                <a16:creationId xmlns:a16="http://schemas.microsoft.com/office/drawing/2014/main" id="{DC22BCE8-2FA2-4498-A64F-DF05587E2280}"/>
+                <a16:creationId xmlns:a16="http://schemas.microsoft.com/office/drawing/2014/main" id="{4CC0783B-B347-411C-8518-2FD0677F94DB}"/>
               </a:ext>
             </a:extLst>
           </p:cNvPr>
@@ -5535,7 +5535,7 @@
           <p:cNvPr id="2" name="€149">
             <a:extLst xmlns:a="http://schemas.openxmlformats.org/drawingml/2006/main">
               <a:ext uri="{FF2B5EF4-FFF2-40B4-BE49-F238E27FC236}">
-                <a16:creationId xmlns:a16="http://schemas.microsoft.com/office/drawing/2014/main" id="{A6B6E2F9-5878-4B2E-9172-91458E11789C}"/>
+                <a16:creationId xmlns:a16="http://schemas.microsoft.com/office/drawing/2014/main" id="{47581963-7819-4D7D-BC92-723BBF2E27E9}"/>
               </a:ext>
             </a:extLst>
           </p:cNvPr>
@@ -5592,7 +5592,7 @@
           <p:cNvPr id="3" name="Illustrative event package, up to 200 people">
             <a:extLst xmlns:a="http://schemas.openxmlformats.org/drawingml/2006/main">
               <a:ext uri="{FF2B5EF4-FFF2-40B4-BE49-F238E27FC236}">
-                <a16:creationId xmlns:a16="http://schemas.microsoft.com/office/drawing/2014/main" id="{8B888D1A-87E0-4D96-BB7F-9B7FEC3CDF31}"/>
+                <a16:creationId xmlns:a16="http://schemas.microsoft.com/office/drawing/2014/main" id="{1C4ADC54-9C14-4683-962C-FB1917A02301}"/>
               </a:ext>
             </a:extLst>
           </p:cNvPr>
@@ -5649,7 +5649,7 @@
           <p:cNvPr id="4" name="20 organizations × 6 events × €149&#10;€17,880 an">
             <a:extLst xmlns:a="http://schemas.openxmlformats.org/drawingml/2006/main">
               <a:ext uri="{FF2B5EF4-FFF2-40B4-BE49-F238E27FC236}">
-                <a16:creationId xmlns:a16="http://schemas.microsoft.com/office/drawing/2014/main" id="{EBDF1C91-6E22-4030-9C29-DFAD77327D9B}"/>
+                <a16:creationId xmlns:a16="http://schemas.microsoft.com/office/drawing/2014/main" id="{2BFEE229-715C-4517-86E2-548355D5F6C8}"/>
               </a:ext>
             </a:extLst>
           </p:cNvPr>
@@ -5729,7 +5729,7 @@
           <p:cNvPr id="5" name="Costs: inference, hosting, support, acquisiti">
             <a:extLst xmlns:a="http://schemas.openxmlformats.org/drawingml/2006/main">
               <a:ext uri="{FF2B5EF4-FFF2-40B4-BE49-F238E27FC236}">
-                <a16:creationId xmlns:a16="http://schemas.microsoft.com/office/drawing/2014/main" id="{958D8C12-E400-4F8D-9417-57ACCE6BF8D7}"/>
+                <a16:creationId xmlns:a16="http://schemas.microsoft.com/office/drawing/2014/main" id="{4CB7C3A7-1879-4091-B983-0729CCC6572E}"/>
               </a:ext>
             </a:extLst>
           </p:cNvPr>
@@ -5786,7 +5786,7 @@
           <p:cNvPr id="6" name="Pricing and volume are hypotheses. Revenue is">
             <a:extLst xmlns:a="http://schemas.openxmlformats.org/drawingml/2006/main">
               <a:ext uri="{FF2B5EF4-FFF2-40B4-BE49-F238E27FC236}">
-                <a16:creationId xmlns:a16="http://schemas.microsoft.com/office/drawing/2014/main" id="{A253B3AA-148F-4548-B78F-78AE4B561C98}"/>
+                <a16:creationId xmlns:a16="http://schemas.microsoft.com/office/drawing/2014/main" id="{3D2508E5-1AE2-41EF-A645-A8E1CF4A8853}"/>
               </a:ext>
             </a:extLst>
           </p:cNvPr>
@@ -5841,7 +5841,7 @@
     </p:spTree>
     <p:extLst>
       <p:ext uri="{BB962C8B-B14F-4D97-AF65-F5344CB8AC3E}">
-        <p14:creationId xmlns:p14="http://schemas.microsoft.com/office/powerpoint/2010/main" val="543923314"/>
+        <p14:creationId xmlns:p14="http://schemas.microsoft.com/office/powerpoint/2010/main" val="514702375"/>
       </p:ext>
     </p:extLst>
   </p:cSld>
@@ -5872,7 +5872,7 @@
           <p:cNvPr id="4" name="A focused start, then wider communities">
             <a:extLst xmlns:a="http://schemas.openxmlformats.org/drawingml/2006/main">
               <a:ext uri="{FF2B5EF4-FFF2-40B4-BE49-F238E27FC236}">
-                <a16:creationId xmlns:a16="http://schemas.microsoft.com/office/drawing/2014/main" id="{DDB8825E-4211-4D09-8CB5-C8160024DB41}"/>
+                <a16:creationId xmlns:a16="http://schemas.microsoft.com/office/drawing/2014/main" id="{9737793E-871D-4E98-BC43-1333878E26AA}"/>
               </a:ext>
             </a:extLst>
           </p:cNvPr>
@@ -5929,7 +5929,7 @@
           <p:cNvPr id="2" name="First: recurring professional and educational">
             <a:extLst xmlns:a="http://schemas.openxmlformats.org/drawingml/2006/main">
               <a:ext uri="{FF2B5EF4-FFF2-40B4-BE49-F238E27FC236}">
-                <a16:creationId xmlns:a16="http://schemas.microsoft.com/office/drawing/2014/main" id="{DD7974ED-EA9D-4AAD-9537-1E2695D43084}"/>
+                <a16:creationId xmlns:a16="http://schemas.microsoft.com/office/drawing/2014/main" id="{D82B5299-9985-4BE7-81E5-F22C4B73E5C8}"/>
               </a:ext>
             </a:extLst>
           </p:cNvPr>
@@ -6014,7 +6014,7 @@
           <p:cNvPr id="3" name="Next milestone: a real organizer pilot">
             <a:extLst xmlns:a="http://schemas.openxmlformats.org/drawingml/2006/main">
               <a:ext uri="{FF2B5EF4-FFF2-40B4-BE49-F238E27FC236}">
-                <a16:creationId xmlns:a16="http://schemas.microsoft.com/office/drawing/2014/main" id="{857E6E50-4011-473A-8B8C-238957859EDC}"/>
+                <a16:creationId xmlns:a16="http://schemas.microsoft.com/office/drawing/2014/main" id="{31C09DB2-4EF7-4C28-9EE3-36C7EEE6AFFD}"/>
               </a:ext>
             </a:extLst>
           </p:cNvPr>
@@ -6069,7 +6069,7 @@
     </p:spTree>
     <p:extLst>
       <p:ext uri="{BB962C8B-B14F-4D97-AF65-F5344CB8AC3E}">
-        <p14:creationId xmlns:p14="http://schemas.microsoft.com/office/powerpoint/2010/main" val="484601969"/>
+        <p14:creationId xmlns:p14="http://schemas.microsoft.com/office/powerpoint/2010/main" val="793820565"/>
       </p:ext>
     </p:extLst>
   </p:cSld>

</xml_diff>